<commit_message>
Refonte visuelle : Frutiger Aero + Isaac
- nouveau design system (verre, reflets, bulles, aqua) — plus de cartes ternes
- accueil : suppression du bloc explicatif, aller a l'essentiel
- grille d'items : une seule plaque de verre, items 40 % plus grands, plus de
  cadres individuels
- chaine : defilement natif (le zoom D3 bloquait la molette), rail de position,
  mur de Dad's Note en travers
- palette du deck alignee, captures regenerees
- d3 retire des dependances
</commit_message>
<xml_diff>
--- a/docs/Spindown-Codex.pptx
+++ b/docs/Spindown-Codex.pptx
@@ -3743,7 +3743,7 @@
             <a:avLst/>
           </a:prstGeom>
           <a:solidFill>
-            <a:srgbClr val="120C0C"/>
+            <a:srgbClr val="04121A"/>
           </a:solidFill>
           <a:ln>
             <a:noFill/>
@@ -3805,7 +3805,7 @@
             <a:r>
               <a:rPr sz="1200" b="0">
                 <a:solidFill>
-                  <a:srgbClr val="B33A3A"/>
+                  <a:srgbClr val="D0453C"/>
                 </a:solidFill>
                 <a:latin typeface="Bahnschrift"/>
               </a:rPr>
@@ -3847,7 +3847,7 @@
             <a:r>
               <a:rPr sz="6200" b="0">
                 <a:solidFill>
-                  <a:srgbClr val="E8D8B0"/>
+                  <a:srgbClr val="E9F7FB"/>
                 </a:solidFill>
                 <a:latin typeface="Bahnschrift"/>
               </a:rPr>
@@ -3871,7 +3871,7 @@
             <a:avLst/>
           </a:prstGeom>
           <a:solidFill>
-            <a:srgbClr val="D4AF37"/>
+            <a:srgbClr val="4FD8E8"/>
           </a:solidFill>
           <a:ln>
             <a:noFill/>
@@ -3933,7 +3933,7 @@
             <a:r>
               <a:rPr sz="2600" b="0">
                 <a:solidFill>
-                  <a:srgbClr val="D4AF37"/>
+                  <a:srgbClr val="4FD8E8"/>
                 </a:solidFill>
                 <a:latin typeface="Bahnschrift"/>
               </a:rPr>
@@ -3975,7 +3975,7 @@
             <a:r>
               <a:rPr sz="1500" b="0">
                 <a:solidFill>
-                  <a:srgbClr val="B6A487"/>
+                  <a:srgbClr val="A9C9D4"/>
                 </a:solidFill>
                 <a:latin typeface="Arial"/>
               </a:rPr>
@@ -4017,7 +4017,7 @@
             <a:r>
               <a:rPr sz="1000" b="0">
                 <a:solidFill>
-                  <a:srgbClr val="847660"/>
+                  <a:srgbClr val="6D94A2"/>
                 </a:solidFill>
                 <a:latin typeface="Arial"/>
               </a:rPr>
@@ -4059,7 +4059,7 @@
             <a:avLst/>
           </a:prstGeom>
           <a:solidFill>
-            <a:srgbClr val="120C0C"/>
+            <a:srgbClr val="04121A"/>
           </a:solidFill>
           <a:ln>
             <a:noFill/>
@@ -4121,7 +4121,7 @@
             <a:r>
               <a:rPr sz="1100" b="0">
                 <a:solidFill>
-                  <a:srgbClr val="D4AF37"/>
+                  <a:srgbClr val="4FD8E8"/>
                 </a:solidFill>
                 <a:latin typeface="Bahnschrift"/>
               </a:rPr>
@@ -4163,7 +4163,7 @@
             <a:r>
               <a:rPr sz="3200" b="0">
                 <a:solidFill>
-                  <a:srgbClr val="E8D8B0"/>
+                  <a:srgbClr val="E9F7FB"/>
                 </a:solidFill>
                 <a:latin typeface="Bahnschrift"/>
               </a:rPr>
@@ -4187,7 +4187,7 @@
             <a:avLst/>
           </a:prstGeom>
           <a:solidFill>
-            <a:srgbClr val="8F7524"/>
+            <a:srgbClr val="2AA8C4"/>
           </a:solidFill>
           <a:ln>
             <a:noFill/>
@@ -4249,7 +4249,7 @@
             <a:r>
               <a:rPr sz="1600" b="0">
                 <a:solidFill>
-                  <a:srgbClr val="B6A487"/>
+                  <a:srgbClr val="A9C9D4"/>
                 </a:solidFill>
                 <a:latin typeface="Arial"/>
               </a:rPr>
@@ -4273,7 +4273,7 @@
             <a:avLst/>
           </a:prstGeom>
           <a:solidFill>
-            <a:srgbClr val="8F7524"/>
+            <a:srgbClr val="2AA8C4"/>
           </a:solidFill>
           <a:ln>
             <a:noFill/>
@@ -4335,7 +4335,7 @@
             <a:r>
               <a:rPr sz="1600" b="0">
                 <a:solidFill>
-                  <a:srgbClr val="B6A487"/>
+                  <a:srgbClr val="A9C9D4"/>
                 </a:solidFill>
                 <a:latin typeface="Arial"/>
               </a:rPr>
@@ -4359,7 +4359,7 @@
             <a:avLst/>
           </a:prstGeom>
           <a:solidFill>
-            <a:srgbClr val="8F7524"/>
+            <a:srgbClr val="2AA8C4"/>
           </a:solidFill>
           <a:ln>
             <a:noFill/>
@@ -4421,7 +4421,7 @@
             <a:r>
               <a:rPr sz="1600" b="0">
                 <a:solidFill>
-                  <a:srgbClr val="B6A487"/>
+                  <a:srgbClr val="A9C9D4"/>
                 </a:solidFill>
                 <a:latin typeface="Arial"/>
               </a:rPr>
@@ -4445,7 +4445,7 @@
             <a:avLst/>
           </a:prstGeom>
           <a:solidFill>
-            <a:srgbClr val="8F7524"/>
+            <a:srgbClr val="2AA8C4"/>
           </a:solidFill>
           <a:ln>
             <a:noFill/>
@@ -4507,7 +4507,7 @@
             <a:r>
               <a:rPr sz="1600" b="0">
                 <a:solidFill>
-                  <a:srgbClr val="B6A487"/>
+                  <a:srgbClr val="A9C9D4"/>
                 </a:solidFill>
                 <a:latin typeface="Arial"/>
               </a:rPr>
@@ -4549,7 +4549,7 @@
             <a:r>
               <a:rPr sz="900" b="0">
                 <a:solidFill>
-                  <a:srgbClr val="847660"/>
+                  <a:srgbClr val="6D94A2"/>
                 </a:solidFill>
                 <a:latin typeface="Arial"/>
               </a:rPr>
@@ -4591,7 +4591,7 @@
             <a:r>
               <a:rPr sz="1000" b="0">
                 <a:solidFill>
-                  <a:srgbClr val="8F7524"/>
+                  <a:srgbClr val="2AA8C4"/>
                 </a:solidFill>
                 <a:latin typeface="Bahnschrift"/>
               </a:rPr>
@@ -4633,7 +4633,7 @@
             <a:avLst/>
           </a:prstGeom>
           <a:solidFill>
-            <a:srgbClr val="120C0C"/>
+            <a:srgbClr val="04121A"/>
           </a:solidFill>
           <a:ln>
             <a:noFill/>
@@ -4695,7 +4695,7 @@
             <a:r>
               <a:rPr sz="1200" b="0">
                 <a:solidFill>
-                  <a:srgbClr val="B33A3A"/>
+                  <a:srgbClr val="D0453C"/>
                 </a:solidFill>
                 <a:latin typeface="Bahnschrift"/>
               </a:rPr>
@@ -4737,7 +4737,7 @@
             <a:r>
               <a:rPr sz="3800" b="0">
                 <a:solidFill>
-                  <a:srgbClr val="E8D8B0"/>
+                  <a:srgbClr val="E9F7FB"/>
                 </a:solidFill>
                 <a:latin typeface="Bahnschrift"/>
               </a:rPr>
@@ -4779,7 +4779,7 @@
             <a:r>
               <a:rPr sz="1500" b="0">
                 <a:solidFill>
-                  <a:srgbClr val="B6A487"/>
+                  <a:srgbClr val="A9C9D4"/>
                 </a:solidFill>
                 <a:latin typeface="Arial"/>
               </a:rPr>
@@ -4803,7 +4803,7 @@
             <a:avLst/>
           </a:prstGeom>
           <a:solidFill>
-            <a:srgbClr val="D4AF37"/>
+            <a:srgbClr val="4FD8E8"/>
           </a:solidFill>
           <a:ln>
             <a:noFill/>
@@ -4865,7 +4865,7 @@
             <a:r>
               <a:rPr sz="2200" b="0">
                 <a:solidFill>
-                  <a:srgbClr val="D4AF37"/>
+                  <a:srgbClr val="4FD8E8"/>
                 </a:solidFill>
                 <a:latin typeface="Bahnschrift"/>
               </a:rPr>
@@ -4907,7 +4907,7 @@
             <a:r>
               <a:rPr sz="900" b="0">
                 <a:solidFill>
-                  <a:srgbClr val="847660"/>
+                  <a:srgbClr val="6D94A2"/>
                 </a:solidFill>
                 <a:latin typeface="Arial"/>
               </a:rPr>
@@ -4949,7 +4949,7 @@
             <a:r>
               <a:rPr sz="1000" b="0">
                 <a:solidFill>
-                  <a:srgbClr val="8F7524"/>
+                  <a:srgbClr val="2AA8C4"/>
                 </a:solidFill>
                 <a:latin typeface="Bahnschrift"/>
               </a:rPr>
@@ -4991,7 +4991,7 @@
             <a:avLst/>
           </a:prstGeom>
           <a:solidFill>
-            <a:srgbClr val="120C0C"/>
+            <a:srgbClr val="04121A"/>
           </a:solidFill>
           <a:ln>
             <a:noFill/>
@@ -5053,7 +5053,7 @@
             <a:r>
               <a:rPr sz="1100" b="0">
                 <a:solidFill>
-                  <a:srgbClr val="D4AF37"/>
+                  <a:srgbClr val="4FD8E8"/>
                 </a:solidFill>
                 <a:latin typeface="Bahnschrift"/>
               </a:rPr>
@@ -5095,7 +5095,7 @@
             <a:r>
               <a:rPr sz="3200" b="0">
                 <a:solidFill>
-                  <a:srgbClr val="E8D8B0"/>
+                  <a:srgbClr val="E9F7FB"/>
                 </a:solidFill>
                 <a:latin typeface="Bahnschrift"/>
               </a:rPr>
@@ -5119,7 +5119,7 @@
             <a:avLst/>
           </a:prstGeom>
           <a:solidFill>
-            <a:srgbClr val="8F7524"/>
+            <a:srgbClr val="2AA8C4"/>
           </a:solidFill>
           <a:ln>
             <a:noFill/>
@@ -5181,7 +5181,7 @@
             <a:r>
               <a:rPr sz="1900" b="0">
                 <a:solidFill>
-                  <a:srgbClr val="E8D8B0"/>
+                  <a:srgbClr val="E9F7FB"/>
                 </a:solidFill>
                 <a:latin typeface="Arial"/>
               </a:rPr>
@@ -5205,7 +5205,7 @@
             <a:avLst/>
           </a:prstGeom>
           <a:solidFill>
-            <a:srgbClr val="8F7524"/>
+            <a:srgbClr val="2AA8C4"/>
           </a:solidFill>
           <a:ln>
             <a:noFill/>
@@ -5267,7 +5267,7 @@
             <a:r>
               <a:rPr sz="1900" b="0">
                 <a:solidFill>
-                  <a:srgbClr val="E8D8B0"/>
+                  <a:srgbClr val="E9F7FB"/>
                 </a:solidFill>
                 <a:latin typeface="Arial"/>
               </a:rPr>
@@ -5291,7 +5291,7 @@
             <a:avLst/>
           </a:prstGeom>
           <a:solidFill>
-            <a:srgbClr val="8F7524"/>
+            <a:srgbClr val="2AA8C4"/>
           </a:solidFill>
           <a:ln>
             <a:noFill/>
@@ -5353,7 +5353,7 @@
             <a:r>
               <a:rPr sz="1900" b="0">
                 <a:solidFill>
-                  <a:srgbClr val="D4AF37"/>
+                  <a:srgbClr val="4FD8E8"/>
                 </a:solidFill>
                 <a:latin typeface="Arial"/>
               </a:rPr>
@@ -5395,7 +5395,7 @@
             <a:r>
               <a:rPr sz="1500" b="0">
                 <a:solidFill>
-                  <a:srgbClr val="B6A487"/>
+                  <a:srgbClr val="A9C9D4"/>
                 </a:solidFill>
                 <a:latin typeface="Arial"/>
               </a:rPr>
@@ -5437,7 +5437,7 @@
             <a:r>
               <a:rPr sz="900" b="0">
                 <a:solidFill>
-                  <a:srgbClr val="847660"/>
+                  <a:srgbClr val="6D94A2"/>
                 </a:solidFill>
                 <a:latin typeface="Arial"/>
               </a:rPr>
@@ -5479,7 +5479,7 @@
             <a:r>
               <a:rPr sz="1000" b="0">
                 <a:solidFill>
-                  <a:srgbClr val="8F7524"/>
+                  <a:srgbClr val="2AA8C4"/>
                 </a:solidFill>
                 <a:latin typeface="Bahnschrift"/>
               </a:rPr>
@@ -5521,7 +5521,7 @@
             <a:avLst/>
           </a:prstGeom>
           <a:solidFill>
-            <a:srgbClr val="120C0C"/>
+            <a:srgbClr val="04121A"/>
           </a:solidFill>
           <a:ln>
             <a:noFill/>
@@ -5583,7 +5583,7 @@
             <a:r>
               <a:rPr sz="1100" b="0">
                 <a:solidFill>
-                  <a:srgbClr val="D4AF37"/>
+                  <a:srgbClr val="4FD8E8"/>
                 </a:solidFill>
                 <a:latin typeface="Bahnschrift"/>
               </a:rPr>
@@ -5625,7 +5625,7 @@
             <a:r>
               <a:rPr sz="3200" b="0">
                 <a:solidFill>
-                  <a:srgbClr val="E8D8B0"/>
+                  <a:srgbClr val="E9F7FB"/>
                 </a:solidFill>
                 <a:latin typeface="Bahnschrift"/>
               </a:rPr>
@@ -5667,7 +5667,7 @@
             <a:r>
               <a:rPr sz="1350" b="0">
                 <a:solidFill>
-                  <a:srgbClr val="B6A487"/>
+                  <a:srgbClr val="A9C9D4"/>
                 </a:solidFill>
                 <a:latin typeface="Arial"/>
               </a:rPr>
@@ -5684,18 +5684,18 @@
         </p:nvSpPr>
         <p:spPr>
           <a:xfrm>
-            <a:off x="5231282" y="1719072"/>
-            <a:ext cx="6042355" cy="4352544"/>
+            <a:off x="4902708" y="1719072"/>
+            <a:ext cx="6699504" cy="4352544"/>
           </a:xfrm>
           <a:prstGeom prst="rect">
             <a:avLst/>
           </a:prstGeom>
           <a:solidFill>
-            <a:srgbClr val="1E1413"/>
+            <a:srgbClr val="0A2A36"/>
           </a:solidFill>
           <a:ln w="12700">
             <a:solidFill>
-              <a:srgbClr val="8F7524"/>
+              <a:srgbClr val="2AA8C4"/>
             </a:solidFill>
           </a:ln>
           <a:effectLst/>
@@ -5738,8 +5738,8 @@
         </p:blipFill>
         <p:spPr>
           <a:xfrm>
-            <a:off x="5295290" y="1783080"/>
-            <a:ext cx="5914339" cy="4224528"/>
+            <a:off x="4966716" y="1783080"/>
+            <a:ext cx="6571488" cy="4224528"/>
           </a:xfrm>
           <a:prstGeom prst="rect">
             <a:avLst/>
@@ -5779,7 +5779,7 @@
             <a:r>
               <a:rPr sz="900" b="0">
                 <a:solidFill>
-                  <a:srgbClr val="847660"/>
+                  <a:srgbClr val="6D94A2"/>
                 </a:solidFill>
                 <a:latin typeface="Arial"/>
               </a:rPr>
@@ -5821,7 +5821,7 @@
             <a:r>
               <a:rPr sz="1000" b="0">
                 <a:solidFill>
-                  <a:srgbClr val="8F7524"/>
+                  <a:srgbClr val="2AA8C4"/>
                 </a:solidFill>
                 <a:latin typeface="Bahnschrift"/>
               </a:rPr>
@@ -5863,7 +5863,7 @@
             <a:avLst/>
           </a:prstGeom>
           <a:solidFill>
-            <a:srgbClr val="120C0C"/>
+            <a:srgbClr val="04121A"/>
           </a:solidFill>
           <a:ln>
             <a:noFill/>
@@ -5925,7 +5925,7 @@
             <a:r>
               <a:rPr sz="1100" b="0">
                 <a:solidFill>
-                  <a:srgbClr val="D4AF37"/>
+                  <a:srgbClr val="4FD8E8"/>
                 </a:solidFill>
                 <a:latin typeface="Bahnschrift"/>
               </a:rPr>
@@ -5967,7 +5967,7 @@
             <a:r>
               <a:rPr sz="3200" b="0">
                 <a:solidFill>
-                  <a:srgbClr val="E8D8B0"/>
+                  <a:srgbClr val="E9F7FB"/>
                 </a:solidFill>
                 <a:latin typeface="Bahnschrift"/>
               </a:rPr>
@@ -6009,11 +6009,11 @@
             <a:r>
               <a:rPr sz="1350" b="0">
                 <a:solidFill>
-                  <a:srgbClr val="B6A487"/>
+                  <a:srgbClr val="A9C9D4"/>
                 </a:solidFill>
                 <a:latin typeface="Arial"/>
               </a:rPr>
-              <a:t>Colonne zoomable, sprites chargés à la demande. Le mur de Dad's Note est dessiné en travers : tout ce qui est en dessous est inatteignable depuis le haut.</a:t>
+              <a:t>La chaîne défile comme une page normale, avec un rail de position à droite. Le mur de Dad's Note coupe la liste : en dessous, plus rien n'est atteignable.</a:t>
             </a:r>
           </a:p>
         </p:txBody>
@@ -6033,11 +6033,11 @@
             <a:avLst/>
           </a:prstGeom>
           <a:solidFill>
-            <a:srgbClr val="1E1413"/>
+            <a:srgbClr val="0A2A36"/>
           </a:solidFill>
           <a:ln w="12700">
             <a:solidFill>
-              <a:srgbClr val="8F7524"/>
+              <a:srgbClr val="2AA8C4"/>
             </a:solidFill>
           </a:ln>
           <a:effectLst/>
@@ -6121,7 +6121,7 @@
             <a:r>
               <a:rPr sz="900" b="0">
                 <a:solidFill>
-                  <a:srgbClr val="847660"/>
+                  <a:srgbClr val="6D94A2"/>
                 </a:solidFill>
                 <a:latin typeface="Arial"/>
               </a:rPr>
@@ -6163,7 +6163,7 @@
             <a:r>
               <a:rPr sz="1000" b="0">
                 <a:solidFill>
-                  <a:srgbClr val="8F7524"/>
+                  <a:srgbClr val="2AA8C4"/>
                 </a:solidFill>
                 <a:latin typeface="Bahnschrift"/>
               </a:rPr>
@@ -6205,7 +6205,7 @@
             <a:avLst/>
           </a:prstGeom>
           <a:solidFill>
-            <a:srgbClr val="120C0C"/>
+            <a:srgbClr val="04121A"/>
           </a:solidFill>
           <a:ln>
             <a:noFill/>
@@ -6267,7 +6267,7 @@
             <a:r>
               <a:rPr sz="1100" b="0">
                 <a:solidFill>
-                  <a:srgbClr val="D4AF37"/>
+                  <a:srgbClr val="4FD8E8"/>
                 </a:solidFill>
                 <a:latin typeface="Bahnschrift"/>
               </a:rPr>
@@ -6309,7 +6309,7 @@
             <a:r>
               <a:rPr sz="3200" b="0">
                 <a:solidFill>
-                  <a:srgbClr val="E8D8B0"/>
+                  <a:srgbClr val="E9F7FB"/>
                 </a:solidFill>
                 <a:latin typeface="Bahnschrift"/>
               </a:rPr>
@@ -6351,7 +6351,7 @@
             <a:r>
               <a:rPr sz="1350" b="0">
                 <a:solidFill>
-                  <a:srgbClr val="B6A487"/>
+                  <a:srgbClr val="A9C9D4"/>
                 </a:solidFill>
                 <a:latin typeface="Arial"/>
               </a:rPr>
@@ -6375,11 +6375,11 @@
             <a:avLst/>
           </a:prstGeom>
           <a:solidFill>
-            <a:srgbClr val="1E1413"/>
+            <a:srgbClr val="0A2A36"/>
           </a:solidFill>
           <a:ln w="12700">
             <a:solidFill>
-              <a:srgbClr val="8F7524"/>
+              <a:srgbClr val="2AA8C4"/>
             </a:solidFill>
           </a:ln>
           <a:effectLst/>
@@ -6463,7 +6463,7 @@
             <a:r>
               <a:rPr sz="900" b="0">
                 <a:solidFill>
-                  <a:srgbClr val="847660"/>
+                  <a:srgbClr val="6D94A2"/>
                 </a:solidFill>
                 <a:latin typeface="Arial"/>
               </a:rPr>
@@ -6505,7 +6505,7 @@
             <a:r>
               <a:rPr sz="1000" b="0">
                 <a:solidFill>
-                  <a:srgbClr val="8F7524"/>
+                  <a:srgbClr val="2AA8C4"/>
                 </a:solidFill>
                 <a:latin typeface="Bahnschrift"/>
               </a:rPr>
@@ -6547,7 +6547,7 @@
             <a:avLst/>
           </a:prstGeom>
           <a:solidFill>
-            <a:srgbClr val="120C0C"/>
+            <a:srgbClr val="04121A"/>
           </a:solidFill>
           <a:ln>
             <a:noFill/>
@@ -6609,7 +6609,7 @@
             <a:r>
               <a:rPr sz="1100" b="0">
                 <a:solidFill>
-                  <a:srgbClr val="D4AF37"/>
+                  <a:srgbClr val="4FD8E8"/>
                 </a:solidFill>
                 <a:latin typeface="Bahnschrift"/>
               </a:rPr>
@@ -6651,7 +6651,7 @@
             <a:r>
               <a:rPr sz="3200" b="0">
                 <a:solidFill>
-                  <a:srgbClr val="E8D8B0"/>
+                  <a:srgbClr val="E9F7FB"/>
                 </a:solidFill>
                 <a:latin typeface="Bahnschrift"/>
               </a:rPr>
@@ -6693,7 +6693,7 @@
             <a:r>
               <a:rPr sz="1350" b="0">
                 <a:solidFill>
-                  <a:srgbClr val="B6A487"/>
+                  <a:srgbClr val="A9C9D4"/>
                 </a:solidFill>
                 <a:latin typeface="Arial"/>
               </a:rPr>
@@ -6717,11 +6717,11 @@
             <a:avLst/>
           </a:prstGeom>
           <a:solidFill>
-            <a:srgbClr val="1E1413"/>
+            <a:srgbClr val="0A2A36"/>
           </a:solidFill>
           <a:ln w="12700">
             <a:solidFill>
-              <a:srgbClr val="8F7524"/>
+              <a:srgbClr val="2AA8C4"/>
             </a:solidFill>
           </a:ln>
           <a:effectLst/>
@@ -6805,7 +6805,7 @@
             <a:r>
               <a:rPr sz="900" b="0">
                 <a:solidFill>
-                  <a:srgbClr val="847660"/>
+                  <a:srgbClr val="6D94A2"/>
                 </a:solidFill>
                 <a:latin typeface="Arial"/>
               </a:rPr>
@@ -6847,7 +6847,7 @@
             <a:r>
               <a:rPr sz="1000" b="0">
                 <a:solidFill>
-                  <a:srgbClr val="8F7524"/>
+                  <a:srgbClr val="2AA8C4"/>
                 </a:solidFill>
                 <a:latin typeface="Bahnschrift"/>
               </a:rPr>
@@ -6889,7 +6889,7 @@
             <a:avLst/>
           </a:prstGeom>
           <a:solidFill>
-            <a:srgbClr val="120C0C"/>
+            <a:srgbClr val="04121A"/>
           </a:solidFill>
           <a:ln>
             <a:noFill/>
@@ -6951,7 +6951,7 @@
             <a:r>
               <a:rPr sz="1100" b="0">
                 <a:solidFill>
-                  <a:srgbClr val="D4AF37"/>
+                  <a:srgbClr val="4FD8E8"/>
                 </a:solidFill>
                 <a:latin typeface="Bahnschrift"/>
               </a:rPr>
@@ -6993,7 +6993,7 @@
             <a:r>
               <a:rPr sz="3200" b="0">
                 <a:solidFill>
-                  <a:srgbClr val="E8D8B0"/>
+                  <a:srgbClr val="E9F7FB"/>
                 </a:solidFill>
                 <a:latin typeface="Bahnschrift"/>
               </a:rPr>
@@ -7035,7 +7035,7 @@
             <a:r>
               <a:rPr sz="1350" b="0">
                 <a:solidFill>
-                  <a:srgbClr val="B6A487"/>
+                  <a:srgbClr val="A9C9D4"/>
                 </a:solidFill>
                 <a:latin typeface="Arial"/>
               </a:rPr>
@@ -7052,18 +7052,18 @@
         </p:nvSpPr>
         <p:spPr>
           <a:xfrm>
-            <a:off x="5231282" y="1719072"/>
-            <a:ext cx="6042355" cy="4352544"/>
+            <a:off x="4902708" y="1719072"/>
+            <a:ext cx="6699504" cy="4352544"/>
           </a:xfrm>
           <a:prstGeom prst="rect">
             <a:avLst/>
           </a:prstGeom>
           <a:solidFill>
-            <a:srgbClr val="1E1413"/>
+            <a:srgbClr val="0A2A36"/>
           </a:solidFill>
           <a:ln w="12700">
             <a:solidFill>
-              <a:srgbClr val="8F7524"/>
+              <a:srgbClr val="2AA8C4"/>
             </a:solidFill>
           </a:ln>
           <a:effectLst/>
@@ -7106,8 +7106,8 @@
         </p:blipFill>
         <p:spPr>
           <a:xfrm>
-            <a:off x="5295290" y="1783080"/>
-            <a:ext cx="5914339" cy="4224528"/>
+            <a:off x="4966716" y="1783080"/>
+            <a:ext cx="6571488" cy="4224528"/>
           </a:xfrm>
           <a:prstGeom prst="rect">
             <a:avLst/>
@@ -7147,7 +7147,7 @@
             <a:r>
               <a:rPr sz="900" b="0">
                 <a:solidFill>
-                  <a:srgbClr val="847660"/>
+                  <a:srgbClr val="6D94A2"/>
                 </a:solidFill>
                 <a:latin typeface="Arial"/>
               </a:rPr>
@@ -7189,7 +7189,7 @@
             <a:r>
               <a:rPr sz="1000" b="0">
                 <a:solidFill>
-                  <a:srgbClr val="8F7524"/>
+                  <a:srgbClr val="2AA8C4"/>
                 </a:solidFill>
                 <a:latin typeface="Bahnschrift"/>
               </a:rPr>
@@ -7231,7 +7231,7 @@
             <a:avLst/>
           </a:prstGeom>
           <a:solidFill>
-            <a:srgbClr val="120C0C"/>
+            <a:srgbClr val="04121A"/>
           </a:solidFill>
           <a:ln>
             <a:noFill/>
@@ -7293,7 +7293,7 @@
             <a:r>
               <a:rPr sz="1100" b="0">
                 <a:solidFill>
-                  <a:srgbClr val="D4AF37"/>
+                  <a:srgbClr val="4FD8E8"/>
                 </a:solidFill>
                 <a:latin typeface="Bahnschrift"/>
               </a:rPr>
@@ -7335,7 +7335,7 @@
             <a:r>
               <a:rPr sz="3200" b="0">
                 <a:solidFill>
-                  <a:srgbClr val="E8D8B0"/>
+                  <a:srgbClr val="E9F7FB"/>
                 </a:solidFill>
                 <a:latin typeface="Bahnschrift"/>
               </a:rPr>
@@ -7375,7 +7375,7 @@
                       <a:r>
                         <a:rPr sz="1200" b="1">
                           <a:solidFill>
-                            <a:srgbClr val="B6A487"/>
+                            <a:srgbClr val="A9C9D4"/>
                           </a:solidFill>
                           <a:latin typeface="Arial"/>
                         </a:rPr>
@@ -7386,26 +7386,26 @@
                   <a:tcPr marL="128016" marT="73152" marB="73152" anchor="ctr">
                     <a:lnL w="9525" cap="flat" cmpd="sng" algn="ctr">
                       <a:solidFill>
-                        <a:srgbClr val="3A2B26"/>
+                        <a:srgbClr val="1E5666"/>
                       </a:solidFill>
                     </a:lnL>
                     <a:lnR w="9525" cap="flat" cmpd="sng" algn="ctr">
                       <a:solidFill>
-                        <a:srgbClr val="3A2B26"/>
+                        <a:srgbClr val="1E5666"/>
                       </a:solidFill>
                     </a:lnR>
                     <a:lnT w="9525" cap="flat" cmpd="sng" algn="ctr">
                       <a:solidFill>
-                        <a:srgbClr val="3A2B26"/>
+                        <a:srgbClr val="1E5666"/>
                       </a:solidFill>
                     </a:lnT>
                     <a:lnB w="9525" cap="flat" cmpd="sng" algn="ctr">
                       <a:solidFill>
-                        <a:srgbClr val="3A2B26"/>
+                        <a:srgbClr val="1E5666"/>
                       </a:solidFill>
                     </a:lnB>
                     <a:solidFill>
-                      <a:srgbClr val="120C0C"/>
+                      <a:srgbClr val="04121A"/>
                     </a:solidFill>
                   </a:tcPr>
                 </a:tc>
@@ -7417,7 +7417,7 @@
                       <a:r>
                         <a:rPr sz="1200" b="1">
                           <a:solidFill>
-                            <a:srgbClr val="B6A487"/>
+                            <a:srgbClr val="A9C9D4"/>
                           </a:solidFill>
                           <a:latin typeface="Arial"/>
                         </a:rPr>
@@ -7428,26 +7428,26 @@
                   <a:tcPr marL="128016" marT="73152" marB="73152" anchor="ctr">
                     <a:lnL w="9525" cap="flat" cmpd="sng" algn="ctr">
                       <a:solidFill>
-                        <a:srgbClr val="3A2B26"/>
+                        <a:srgbClr val="1E5666"/>
                       </a:solidFill>
                     </a:lnL>
                     <a:lnR w="9525" cap="flat" cmpd="sng" algn="ctr">
                       <a:solidFill>
-                        <a:srgbClr val="3A2B26"/>
+                        <a:srgbClr val="1E5666"/>
                       </a:solidFill>
                     </a:lnR>
                     <a:lnT w="9525" cap="flat" cmpd="sng" algn="ctr">
                       <a:solidFill>
-                        <a:srgbClr val="3A2B26"/>
+                        <a:srgbClr val="1E5666"/>
                       </a:solidFill>
                     </a:lnT>
                     <a:lnB w="9525" cap="flat" cmpd="sng" algn="ctr">
                       <a:solidFill>
-                        <a:srgbClr val="3A2B26"/>
+                        <a:srgbClr val="1E5666"/>
                       </a:solidFill>
                     </a:lnB>
                     <a:solidFill>
-                      <a:srgbClr val="120C0C"/>
+                      <a:srgbClr val="04121A"/>
                     </a:solidFill>
                   </a:tcPr>
                 </a:tc>
@@ -7461,7 +7461,7 @@
                       <a:r>
                         <a:rPr sz="1300" b="0">
                           <a:solidFill>
-                            <a:srgbClr val="B6A487"/>
+                            <a:srgbClr val="A9C9D4"/>
                           </a:solidFill>
                           <a:latin typeface="Arial"/>
                         </a:rPr>
@@ -7472,26 +7472,26 @@
                   <a:tcPr marL="128016" marT="73152" marB="73152" anchor="ctr">
                     <a:lnL w="9525" cap="flat" cmpd="sng" algn="ctr">
                       <a:solidFill>
-                        <a:srgbClr val="3A2B26"/>
+                        <a:srgbClr val="1E5666"/>
                       </a:solidFill>
                     </a:lnL>
                     <a:lnR w="9525" cap="flat" cmpd="sng" algn="ctr">
                       <a:solidFill>
-                        <a:srgbClr val="3A2B26"/>
+                        <a:srgbClr val="1E5666"/>
                       </a:solidFill>
                     </a:lnR>
                     <a:lnT w="9525" cap="flat" cmpd="sng" algn="ctr">
                       <a:solidFill>
-                        <a:srgbClr val="3A2B26"/>
+                        <a:srgbClr val="1E5666"/>
                       </a:solidFill>
                     </a:lnT>
                     <a:lnB w="9525" cap="flat" cmpd="sng" algn="ctr">
                       <a:solidFill>
-                        <a:srgbClr val="3A2B26"/>
+                        <a:srgbClr val="1E5666"/>
                       </a:solidFill>
                     </a:lnB>
                     <a:solidFill>
-                      <a:srgbClr val="1E1413"/>
+                      <a:srgbClr val="0A2A36"/>
                     </a:solidFill>
                   </a:tcPr>
                 </a:tc>
@@ -7503,7 +7503,7 @@
                       <a:r>
                         <a:rPr sz="1300" b="0">
                           <a:solidFill>
-                            <a:srgbClr val="D4AF37"/>
+                            <a:srgbClr val="4FD8E8"/>
                           </a:solidFill>
                           <a:latin typeface="Arial"/>
                         </a:rPr>
@@ -7514,26 +7514,26 @@
                   <a:tcPr marL="128016" marT="73152" marB="73152" anchor="ctr">
                     <a:lnL w="9525" cap="flat" cmpd="sng" algn="ctr">
                       <a:solidFill>
-                        <a:srgbClr val="3A2B26"/>
+                        <a:srgbClr val="1E5666"/>
                       </a:solidFill>
                     </a:lnL>
                     <a:lnR w="9525" cap="flat" cmpd="sng" algn="ctr">
                       <a:solidFill>
-                        <a:srgbClr val="3A2B26"/>
+                        <a:srgbClr val="1E5666"/>
                       </a:solidFill>
                     </a:lnR>
                     <a:lnT w="9525" cap="flat" cmpd="sng" algn="ctr">
                       <a:solidFill>
-                        <a:srgbClr val="3A2B26"/>
+                        <a:srgbClr val="1E5666"/>
                       </a:solidFill>
                     </a:lnT>
                     <a:lnB w="9525" cap="flat" cmpd="sng" algn="ctr">
                       <a:solidFill>
-                        <a:srgbClr val="3A2B26"/>
+                        <a:srgbClr val="1E5666"/>
                       </a:solidFill>
                     </a:lnB>
                     <a:solidFill>
-                      <a:srgbClr val="1E1413"/>
+                      <a:srgbClr val="0A2A36"/>
                     </a:solidFill>
                   </a:tcPr>
                 </a:tc>
@@ -7547,7 +7547,7 @@
                       <a:r>
                         <a:rPr sz="1300" b="0">
                           <a:solidFill>
-                            <a:srgbClr val="B6A487"/>
+                            <a:srgbClr val="A9C9D4"/>
                           </a:solidFill>
                           <a:latin typeface="Arial"/>
                         </a:rPr>
@@ -7558,26 +7558,26 @@
                   <a:tcPr marL="128016" marT="73152" marB="73152" anchor="ctr">
                     <a:lnL w="9525" cap="flat" cmpd="sng" algn="ctr">
                       <a:solidFill>
-                        <a:srgbClr val="3A2B26"/>
+                        <a:srgbClr val="1E5666"/>
                       </a:solidFill>
                     </a:lnL>
                     <a:lnR w="9525" cap="flat" cmpd="sng" algn="ctr">
                       <a:solidFill>
-                        <a:srgbClr val="3A2B26"/>
+                        <a:srgbClr val="1E5666"/>
                       </a:solidFill>
                     </a:lnR>
                     <a:lnT w="9525" cap="flat" cmpd="sng" algn="ctr">
                       <a:solidFill>
-                        <a:srgbClr val="3A2B26"/>
+                        <a:srgbClr val="1E5666"/>
                       </a:solidFill>
                     </a:lnT>
                     <a:lnB w="9525" cap="flat" cmpd="sng" algn="ctr">
                       <a:solidFill>
-                        <a:srgbClr val="3A2B26"/>
+                        <a:srgbClr val="1E5666"/>
                       </a:solidFill>
                     </a:lnB>
                     <a:solidFill>
-                      <a:srgbClr val="1E1413"/>
+                      <a:srgbClr val="0A2A36"/>
                     </a:solidFill>
                   </a:tcPr>
                 </a:tc>
@@ -7589,7 +7589,7 @@
                       <a:r>
                         <a:rPr sz="1300" b="0">
                           <a:solidFill>
-                            <a:srgbClr val="D4AF37"/>
+                            <a:srgbClr val="4FD8E8"/>
                           </a:solidFill>
                           <a:latin typeface="Arial"/>
                         </a:rPr>
@@ -7600,26 +7600,26 @@
                   <a:tcPr marL="128016" marT="73152" marB="73152" anchor="ctr">
                     <a:lnL w="9525" cap="flat" cmpd="sng" algn="ctr">
                       <a:solidFill>
-                        <a:srgbClr val="3A2B26"/>
+                        <a:srgbClr val="1E5666"/>
                       </a:solidFill>
                     </a:lnL>
                     <a:lnR w="9525" cap="flat" cmpd="sng" algn="ctr">
                       <a:solidFill>
-                        <a:srgbClr val="3A2B26"/>
+                        <a:srgbClr val="1E5666"/>
                       </a:solidFill>
                     </a:lnR>
                     <a:lnT w="9525" cap="flat" cmpd="sng" algn="ctr">
                       <a:solidFill>
-                        <a:srgbClr val="3A2B26"/>
+                        <a:srgbClr val="1E5666"/>
                       </a:solidFill>
                     </a:lnT>
                     <a:lnB w="9525" cap="flat" cmpd="sng" algn="ctr">
                       <a:solidFill>
-                        <a:srgbClr val="3A2B26"/>
+                        <a:srgbClr val="1E5666"/>
                       </a:solidFill>
                     </a:lnB>
                     <a:solidFill>
-                      <a:srgbClr val="1E1413"/>
+                      <a:srgbClr val="0A2A36"/>
                     </a:solidFill>
                   </a:tcPr>
                 </a:tc>
@@ -7633,7 +7633,7 @@
                       <a:r>
                         <a:rPr sz="1300" b="0">
                           <a:solidFill>
-                            <a:srgbClr val="B6A487"/>
+                            <a:srgbClr val="A9C9D4"/>
                           </a:solidFill>
                           <a:latin typeface="Arial"/>
                         </a:rPr>
@@ -7644,26 +7644,26 @@
                   <a:tcPr marL="128016" marT="73152" marB="73152" anchor="ctr">
                     <a:lnL w="9525" cap="flat" cmpd="sng" algn="ctr">
                       <a:solidFill>
-                        <a:srgbClr val="3A2B26"/>
+                        <a:srgbClr val="1E5666"/>
                       </a:solidFill>
                     </a:lnL>
                     <a:lnR w="9525" cap="flat" cmpd="sng" algn="ctr">
                       <a:solidFill>
-                        <a:srgbClr val="3A2B26"/>
+                        <a:srgbClr val="1E5666"/>
                       </a:solidFill>
                     </a:lnR>
                     <a:lnT w="9525" cap="flat" cmpd="sng" algn="ctr">
                       <a:solidFill>
-                        <a:srgbClr val="3A2B26"/>
+                        <a:srgbClr val="1E5666"/>
                       </a:solidFill>
                     </a:lnT>
                     <a:lnB w="9525" cap="flat" cmpd="sng" algn="ctr">
                       <a:solidFill>
-                        <a:srgbClr val="3A2B26"/>
+                        <a:srgbClr val="1E5666"/>
                       </a:solidFill>
                     </a:lnB>
                     <a:solidFill>
-                      <a:srgbClr val="1E1413"/>
+                      <a:srgbClr val="0A2A36"/>
                     </a:solidFill>
                   </a:tcPr>
                 </a:tc>
@@ -7675,7 +7675,7 @@
                       <a:r>
                         <a:rPr sz="1300" b="0">
                           <a:solidFill>
-                            <a:srgbClr val="D4AF37"/>
+                            <a:srgbClr val="4FD8E8"/>
                           </a:solidFill>
                           <a:latin typeface="Arial"/>
                         </a:rPr>
@@ -7686,26 +7686,26 @@
                   <a:tcPr marL="128016" marT="73152" marB="73152" anchor="ctr">
                     <a:lnL w="9525" cap="flat" cmpd="sng" algn="ctr">
                       <a:solidFill>
-                        <a:srgbClr val="3A2B26"/>
+                        <a:srgbClr val="1E5666"/>
                       </a:solidFill>
                     </a:lnL>
                     <a:lnR w="9525" cap="flat" cmpd="sng" algn="ctr">
                       <a:solidFill>
-                        <a:srgbClr val="3A2B26"/>
+                        <a:srgbClr val="1E5666"/>
                       </a:solidFill>
                     </a:lnR>
                     <a:lnT w="9525" cap="flat" cmpd="sng" algn="ctr">
                       <a:solidFill>
-                        <a:srgbClr val="3A2B26"/>
+                        <a:srgbClr val="1E5666"/>
                       </a:solidFill>
                     </a:lnT>
                     <a:lnB w="9525" cap="flat" cmpd="sng" algn="ctr">
                       <a:solidFill>
-                        <a:srgbClr val="3A2B26"/>
+                        <a:srgbClr val="1E5666"/>
                       </a:solidFill>
                     </a:lnB>
                     <a:solidFill>
-                      <a:srgbClr val="1E1413"/>
+                      <a:srgbClr val="0A2A36"/>
                     </a:solidFill>
                   </a:tcPr>
                 </a:tc>
@@ -7719,7 +7719,7 @@
                       <a:r>
                         <a:rPr sz="1300" b="0">
                           <a:solidFill>
-                            <a:srgbClr val="B6A487"/>
+                            <a:srgbClr val="A9C9D4"/>
                           </a:solidFill>
                           <a:latin typeface="Arial"/>
                         </a:rPr>
@@ -7730,26 +7730,26 @@
                   <a:tcPr marL="128016" marT="73152" marB="73152" anchor="ctr">
                     <a:lnL w="9525" cap="flat" cmpd="sng" algn="ctr">
                       <a:solidFill>
-                        <a:srgbClr val="3A2B26"/>
+                        <a:srgbClr val="1E5666"/>
                       </a:solidFill>
                     </a:lnL>
                     <a:lnR w="9525" cap="flat" cmpd="sng" algn="ctr">
                       <a:solidFill>
-                        <a:srgbClr val="3A2B26"/>
+                        <a:srgbClr val="1E5666"/>
                       </a:solidFill>
                     </a:lnR>
                     <a:lnT w="9525" cap="flat" cmpd="sng" algn="ctr">
                       <a:solidFill>
-                        <a:srgbClr val="3A2B26"/>
+                        <a:srgbClr val="1E5666"/>
                       </a:solidFill>
                     </a:lnT>
                     <a:lnB w="9525" cap="flat" cmpd="sng" algn="ctr">
                       <a:solidFill>
-                        <a:srgbClr val="3A2B26"/>
+                        <a:srgbClr val="1E5666"/>
                       </a:solidFill>
                     </a:lnB>
                     <a:solidFill>
-                      <a:srgbClr val="1E1413"/>
+                      <a:srgbClr val="0A2A36"/>
                     </a:solidFill>
                   </a:tcPr>
                 </a:tc>
@@ -7761,7 +7761,7 @@
                       <a:r>
                         <a:rPr sz="1300" b="0">
                           <a:solidFill>
-                            <a:srgbClr val="D4AF37"/>
+                            <a:srgbClr val="4FD8E8"/>
                           </a:solidFill>
                           <a:latin typeface="Arial"/>
                         </a:rPr>
@@ -7772,26 +7772,26 @@
                   <a:tcPr marL="128016" marT="73152" marB="73152" anchor="ctr">
                     <a:lnL w="9525" cap="flat" cmpd="sng" algn="ctr">
                       <a:solidFill>
-                        <a:srgbClr val="3A2B26"/>
+                        <a:srgbClr val="1E5666"/>
                       </a:solidFill>
                     </a:lnL>
                     <a:lnR w="9525" cap="flat" cmpd="sng" algn="ctr">
                       <a:solidFill>
-                        <a:srgbClr val="3A2B26"/>
+                        <a:srgbClr val="1E5666"/>
                       </a:solidFill>
                     </a:lnR>
                     <a:lnT w="9525" cap="flat" cmpd="sng" algn="ctr">
                       <a:solidFill>
-                        <a:srgbClr val="3A2B26"/>
+                        <a:srgbClr val="1E5666"/>
                       </a:solidFill>
                     </a:lnT>
                     <a:lnB w="9525" cap="flat" cmpd="sng" algn="ctr">
                       <a:solidFill>
-                        <a:srgbClr val="3A2B26"/>
+                        <a:srgbClr val="1E5666"/>
                       </a:solidFill>
                     </a:lnB>
                     <a:solidFill>
-                      <a:srgbClr val="1E1413"/>
+                      <a:srgbClr val="0A2A36"/>
                     </a:solidFill>
                   </a:tcPr>
                 </a:tc>
@@ -7833,7 +7833,7 @@
             <a:r>
               <a:rPr sz="1300" b="0">
                 <a:solidFill>
-                  <a:srgbClr val="B6A487"/>
+                  <a:srgbClr val="A9C9D4"/>
                 </a:solidFill>
                 <a:latin typeface="Arial"/>
               </a:rPr>
@@ -7875,7 +7875,7 @@
             <a:r>
               <a:rPr sz="900" b="0">
                 <a:solidFill>
-                  <a:srgbClr val="847660"/>
+                  <a:srgbClr val="6D94A2"/>
                 </a:solidFill>
                 <a:latin typeface="Arial"/>
               </a:rPr>
@@ -7917,7 +7917,7 @@
             <a:r>
               <a:rPr sz="1000" b="0">
                 <a:solidFill>
-                  <a:srgbClr val="8F7524"/>
+                  <a:srgbClr val="2AA8C4"/>
                 </a:solidFill>
                 <a:latin typeface="Bahnschrift"/>
               </a:rPr>
@@ -7959,7 +7959,7 @@
             <a:avLst/>
           </a:prstGeom>
           <a:solidFill>
-            <a:srgbClr val="120C0C"/>
+            <a:srgbClr val="04121A"/>
           </a:solidFill>
           <a:ln>
             <a:noFill/>
@@ -8021,7 +8021,7 @@
             <a:r>
               <a:rPr sz="1100" b="0">
                 <a:solidFill>
-                  <a:srgbClr val="D4AF37"/>
+                  <a:srgbClr val="4FD8E8"/>
                 </a:solidFill>
                 <a:latin typeface="Bahnschrift"/>
               </a:rPr>
@@ -8063,7 +8063,7 @@
             <a:r>
               <a:rPr sz="3200" b="0">
                 <a:solidFill>
-                  <a:srgbClr val="E8D8B0"/>
+                  <a:srgbClr val="E9F7FB"/>
                 </a:solidFill>
                 <a:latin typeface="Bahnschrift"/>
               </a:rPr>
@@ -8087,11 +8087,11 @@
             <a:avLst/>
           </a:prstGeom>
           <a:solidFill>
-            <a:srgbClr val="1E1413"/>
+            <a:srgbClr val="0A2A36"/>
           </a:solidFill>
           <a:ln w="12700">
             <a:solidFill>
-              <a:srgbClr val="8F7524"/>
+              <a:srgbClr val="2AA8C4"/>
             </a:solidFill>
           </a:ln>
           <a:effectLst/>
@@ -8151,7 +8151,7 @@
             <a:r>
               <a:rPr sz="3400" b="0">
                 <a:solidFill>
-                  <a:srgbClr val="D4AF37"/>
+                  <a:srgbClr val="4FD8E8"/>
                 </a:solidFill>
                 <a:latin typeface="Bahnschrift"/>
               </a:rPr>
@@ -8193,7 +8193,7 @@
             <a:r>
               <a:rPr sz="1100" b="0">
                 <a:solidFill>
-                  <a:srgbClr val="B6A487"/>
+                  <a:srgbClr val="A9C9D4"/>
                 </a:solidFill>
                 <a:latin typeface="Arial"/>
               </a:rPr>
@@ -8218,11 +8218,11 @@
             <a:avLst/>
           </a:prstGeom>
           <a:solidFill>
-            <a:srgbClr val="1E1413"/>
+            <a:srgbClr val="0A2A36"/>
           </a:solidFill>
           <a:ln w="12700">
             <a:solidFill>
-              <a:srgbClr val="8F7524"/>
+              <a:srgbClr val="2AA8C4"/>
             </a:solidFill>
           </a:ln>
           <a:effectLst/>
@@ -8282,7 +8282,7 @@
             <a:r>
               <a:rPr sz="3400" b="0">
                 <a:solidFill>
-                  <a:srgbClr val="D4AF37"/>
+                  <a:srgbClr val="4FD8E8"/>
                 </a:solidFill>
                 <a:latin typeface="Bahnschrift"/>
               </a:rPr>
@@ -8324,7 +8324,7 @@
             <a:r>
               <a:rPr sz="1100" b="0">
                 <a:solidFill>
-                  <a:srgbClr val="B6A487"/>
+                  <a:srgbClr val="A9C9D4"/>
                 </a:solidFill>
                 <a:latin typeface="Arial"/>
               </a:rPr>
@@ -8349,11 +8349,11 @@
             <a:avLst/>
           </a:prstGeom>
           <a:solidFill>
-            <a:srgbClr val="1E1413"/>
+            <a:srgbClr val="0A2A36"/>
           </a:solidFill>
           <a:ln w="12700">
             <a:solidFill>
-              <a:srgbClr val="8F7524"/>
+              <a:srgbClr val="2AA8C4"/>
             </a:solidFill>
           </a:ln>
           <a:effectLst/>
@@ -8413,7 +8413,7 @@
             <a:r>
               <a:rPr sz="3400" b="0">
                 <a:solidFill>
-                  <a:srgbClr val="D4AF37"/>
+                  <a:srgbClr val="4FD8E8"/>
                 </a:solidFill>
                 <a:latin typeface="Bahnschrift"/>
               </a:rPr>
@@ -8455,7 +8455,7 @@
             <a:r>
               <a:rPr sz="1100" b="0">
                 <a:solidFill>
-                  <a:srgbClr val="B6A487"/>
+                  <a:srgbClr val="A9C9D4"/>
                 </a:solidFill>
                 <a:latin typeface="Arial"/>
               </a:rPr>
@@ -8480,11 +8480,11 @@
             <a:avLst/>
           </a:prstGeom>
           <a:solidFill>
-            <a:srgbClr val="1E1413"/>
+            <a:srgbClr val="0A2A36"/>
           </a:solidFill>
           <a:ln w="12700">
             <a:solidFill>
-              <a:srgbClr val="8F7524"/>
+              <a:srgbClr val="2AA8C4"/>
             </a:solidFill>
           </a:ln>
           <a:effectLst/>
@@ -8544,7 +8544,7 @@
             <a:r>
               <a:rPr sz="3400" b="0">
                 <a:solidFill>
-                  <a:srgbClr val="D4AF37"/>
+                  <a:srgbClr val="4FD8E8"/>
                 </a:solidFill>
                 <a:latin typeface="Bahnschrift"/>
               </a:rPr>
@@ -8586,7 +8586,7 @@
             <a:r>
               <a:rPr sz="1100" b="0">
                 <a:solidFill>
-                  <a:srgbClr val="B6A487"/>
+                  <a:srgbClr val="A9C9D4"/>
                 </a:solidFill>
                 <a:latin typeface="Arial"/>
               </a:rPr>
@@ -8611,11 +8611,11 @@
             <a:avLst/>
           </a:prstGeom>
           <a:solidFill>
-            <a:srgbClr val="1E1413"/>
+            <a:srgbClr val="0A2A36"/>
           </a:solidFill>
           <a:ln w="12700">
             <a:solidFill>
-              <a:srgbClr val="8F7524"/>
+              <a:srgbClr val="2AA8C4"/>
             </a:solidFill>
           </a:ln>
           <a:effectLst/>
@@ -8675,7 +8675,7 @@
             <a:r>
               <a:rPr sz="3400" b="0">
                 <a:solidFill>
-                  <a:srgbClr val="D4AF37"/>
+                  <a:srgbClr val="4FD8E8"/>
                 </a:solidFill>
                 <a:latin typeface="Bahnschrift"/>
               </a:rPr>
@@ -8717,7 +8717,7 @@
             <a:r>
               <a:rPr sz="1100" b="0">
                 <a:solidFill>
-                  <a:srgbClr val="B6A487"/>
+                  <a:srgbClr val="A9C9D4"/>
                 </a:solidFill>
                 <a:latin typeface="Arial"/>
               </a:rPr>
@@ -8742,11 +8742,11 @@
             <a:avLst/>
           </a:prstGeom>
           <a:solidFill>
-            <a:srgbClr val="1E1413"/>
+            <a:srgbClr val="0A2A36"/>
           </a:solidFill>
           <a:ln w="12700">
             <a:solidFill>
-              <a:srgbClr val="8F7524"/>
+              <a:srgbClr val="2AA8C4"/>
             </a:solidFill>
           </a:ln>
           <a:effectLst/>
@@ -8806,7 +8806,7 @@
             <a:r>
               <a:rPr sz="3400" b="0">
                 <a:solidFill>
-                  <a:srgbClr val="D4AF37"/>
+                  <a:srgbClr val="4FD8E8"/>
                 </a:solidFill>
                 <a:latin typeface="Bahnschrift"/>
               </a:rPr>
@@ -8848,7 +8848,7 @@
             <a:r>
               <a:rPr sz="1100" b="0">
                 <a:solidFill>
-                  <a:srgbClr val="B6A487"/>
+                  <a:srgbClr val="A9C9D4"/>
                 </a:solidFill>
                 <a:latin typeface="Arial"/>
               </a:rPr>
@@ -8891,7 +8891,7 @@
             <a:r>
               <a:rPr sz="900" b="0">
                 <a:solidFill>
-                  <a:srgbClr val="847660"/>
+                  <a:srgbClr val="6D94A2"/>
                 </a:solidFill>
                 <a:latin typeface="Arial"/>
               </a:rPr>
@@ -8933,7 +8933,7 @@
             <a:r>
               <a:rPr sz="1000" b="0">
                 <a:solidFill>
-                  <a:srgbClr val="8F7524"/>
+                  <a:srgbClr val="2AA8C4"/>
                 </a:solidFill>
                 <a:latin typeface="Bahnschrift"/>
               </a:rPr>

</xml_diff>

<commit_message>
Chaine : plus de mur, la liste continue
Dad's Note reste a sa place dans la liste, avec un simple badge
'cannot be rerolled'. Plus de zone grisee ni de frontiere sur toute la page :
la chaine se lit d'un bout a l'autre. Textes et deck alignes.
</commit_message>
<xml_diff>
--- a/docs/Spindown-Codex.pptx
+++ b/docs/Spindown-Codex.pptx
@@ -5971,7 +5971,7 @@
                 </a:solidFill>
                 <a:latin typeface="Bahnschrift"/>
               </a:rPr>
-              <a:t>La chaîne entière, mur compris</a:t>
+              <a:t>La chaîne entière, d'un bout à l'autre</a:t>
             </a:r>
           </a:p>
         </p:txBody>
@@ -6013,7 +6013,7 @@
                 </a:solidFill>
                 <a:latin typeface="Arial"/>
               </a:rPr>
-              <a:t>La chaîne défile comme une page normale, avec un rail de position à droite. Le mur de Dad's Note coupe la liste : en dessous, plus rien n'est atteignable.</a:t>
+              <a:t>Toute la chaîne d'un seul tenant, avec un rail de position à droite. Dad's Note y est signalée par un badge : elle ne peut pas être rerollée.</a:t>
             </a:r>
           </a:p>
         </p:txBody>

</xml_diff>